<commit_message>
Use the PLUMB product logo in the pitch deck and case study PDF
</commit_message>
<xml_diff>
--- a/docs/pitch/PLUMB_Pitch_Deck.pptx
+++ b/docs/pitch/PLUMB_Pitch_Deck.pptx
@@ -1870,16 +1870,40 @@
           <a:chExt cx="0" cy="0"/>
         </a:xfrm>
       </p:grpSpPr>
-      <p:sp>
-        <p:nvSpPr>
-          <p:cNvPr id="2" name="Text 0"/>
-          <p:cNvSpPr txBox="1"/>
-          <p:nvPr/>
-        </p:nvSpPr>
-        <p:spPr>
-          <a:xfrm>
-            <a:off x="640080" y="1097280"/>
-            <a:ext cx="7863840" cy="914400"/>
+      <p:pic>
+        <p:nvPicPr>
+          <p:cNvPr id="2" name="Image 0" descr="logo_w.png">    </p:cNvPr>
+          <p:cNvPicPr>
+            <a:picLocks noChangeAspect="1"/>
+          </p:cNvPicPr>
+          <p:nvPr/>
+        </p:nvPicPr>
+        <p:blipFill>
+          <a:blip r:embed="rId1"/>
+          <a:stretch>
+            <a:fillRect/>
+          </a:stretch>
+        </p:blipFill>
+        <p:spPr>
+          <a:xfrm>
+            <a:off x="640080" y="640080"/>
+            <a:ext cx="324964" cy="384048"/>
+          </a:xfrm>
+          <a:prstGeom prst="rect">
+            <a:avLst/>
+          </a:prstGeom>
+        </p:spPr>
+      </p:pic>
+      <p:sp>
+        <p:nvSpPr>
+          <p:cNvPr id="3" name="Text 0"/>
+          <p:cNvSpPr txBox="1"/>
+          <p:nvPr/>
+        </p:nvSpPr>
+        <p:spPr>
+          <a:xfrm>
+            <a:off x="1093060" y="621792"/>
+            <a:ext cx="1792224" cy="420624"/>
           </a:xfrm>
           <a:prstGeom prst="rect">
             <a:avLst/>
@@ -1895,7 +1919,46 @@
               <a:buNone/>
             </a:pPr>
             <a:r>
-              <a:rPr lang="en-US" sz="6000" b="1" dirty="0">
+              <a:rPr lang="en-US" sz="1680" b="1" spc="400" kern="0" dirty="0">
+                <a:solidFill>
+                  <a:srgbClr val="FFFFFF"/>
+                </a:solidFill>
+                <a:latin typeface="Calibri" pitchFamily="34" charset="0"/>
+                <a:ea typeface="Calibri" pitchFamily="34" charset="-122"/>
+                <a:cs typeface="Calibri" pitchFamily="34" charset="-120"/>
+              </a:rPr>
+              <a:t>PLUMB</a:t>
+            </a:r>
+            <a:endParaRPr lang="en-US" sz="1680" dirty="0"/>
+          </a:p>
+        </p:txBody>
+      </p:sp>
+      <p:sp>
+        <p:nvSpPr>
+          <p:cNvPr id="4" name="Text 1"/>
+          <p:cNvSpPr txBox="1"/>
+          <p:nvPr/>
+        </p:nvSpPr>
+        <p:spPr>
+          <a:xfrm>
+            <a:off x="640080" y="1234440"/>
+            <a:ext cx="7863840" cy="1280160"/>
+          </a:xfrm>
+          <a:prstGeom prst="rect">
+            <a:avLst/>
+          </a:prstGeom>
+          <a:noFill/>
+          <a:ln/>
+        </p:spPr>
+        <p:txBody>
+          <a:bodyPr wrap="square" lIns="0" tIns="0" rIns="0" bIns="0" rtlCol="0" anchor="t"/>
+          <a:lstStyle/>
+          <a:p>
+            <a:pPr indent="0" marL="0">
+              <a:buNone/>
+            </a:pPr>
+            <a:r>
+              <a:rPr lang="en-US" sz="3600" b="1" dirty="0">
                 <a:solidFill>
                   <a:srgbClr val="FFFFFF"/>
                 </a:solidFill>
@@ -1903,21 +1966,38 @@
                 <a:ea typeface="Georgia" pitchFamily="34" charset="-122"/>
                 <a:cs typeface="Georgia" pitchFamily="34" charset="-120"/>
               </a:rPr>
-              <a:t>PLUMB</a:t>
-            </a:r>
-            <a:endParaRPr lang="en-US" sz="6000" dirty="0"/>
-          </a:p>
-        </p:txBody>
-      </p:sp>
-      <p:sp>
-        <p:nvSpPr>
-          <p:cNvPr id="3" name="Shape 1"/>
+              <a:t>Floor pricing,</a:t>
+            </a:r>
+            <a:endParaRPr lang="en-US" sz="3600" dirty="0"/>
+          </a:p>
+          <a:p>
+            <a:pPr indent="0" marL="0">
+              <a:buNone/>
+            </a:pPr>
+            <a:r>
+              <a:rPr lang="en-US" sz="3600" b="1" dirty="0">
+                <a:solidFill>
+                  <a:srgbClr val="FFFFFF"/>
+                </a:solidFill>
+                <a:latin typeface="Georgia" pitchFamily="34" charset="0"/>
+                <a:ea typeface="Georgia" pitchFamily="34" charset="-122"/>
+                <a:cs typeface="Georgia" pitchFamily="34" charset="-120"/>
+              </a:rPr>
+              <a:t>with a human in charge</a:t>
+            </a:r>
+            <a:endParaRPr lang="en-US" sz="3600" dirty="0"/>
+          </a:p>
+        </p:txBody>
+      </p:sp>
+      <p:sp>
+        <p:nvSpPr>
+          <p:cNvPr id="5" name="Shape 2"/>
           <p:cNvSpPr/>
           <p:nvPr/>
         </p:nvSpPr>
         <p:spPr>
           <a:xfrm>
-            <a:off x="640080" y="2103120"/>
+            <a:off x="640080" y="2743200"/>
             <a:ext cx="1097280" cy="54864"/>
           </a:xfrm>
           <a:prstGeom prst="rect">
@@ -1936,14 +2016,14 @@
       </p:sp>
       <p:sp>
         <p:nvSpPr>
-          <p:cNvPr id="4" name="Text 2"/>
-          <p:cNvSpPr txBox="1"/>
-          <p:nvPr/>
-        </p:nvSpPr>
-        <p:spPr>
-          <a:xfrm>
-            <a:off x="640080" y="2331720"/>
-            <a:ext cx="6949440" cy="1005840"/>
+          <p:cNvPr id="6" name="Text 3"/>
+          <p:cNvSpPr txBox="1"/>
+          <p:nvPr/>
+        </p:nvSpPr>
+        <p:spPr>
+          <a:xfrm>
+            <a:off x="640080" y="2971800"/>
+            <a:ext cx="6949440" cy="914400"/>
           </a:xfrm>
           <a:prstGeom prst="rect">
             <a:avLst/>
@@ -1959,7 +2039,7 @@
               <a:buNone/>
             </a:pPr>
             <a:r>
-              <a:rPr lang="en-US" sz="2200" dirty="0">
+              <a:rPr lang="en-US" sz="1800" dirty="0">
                 <a:solidFill>
                   <a:srgbClr val="FFFFFF"/>
                 </a:solidFill>
@@ -1969,13 +2049,13 @@
               </a:rPr>
               <a:t>A floor-pricing partner for ad ops. Statistics propose, an agent can refuse, a human decides.</a:t>
             </a:r>
-            <a:endParaRPr lang="en-US" sz="2200" dirty="0"/>
-          </a:p>
-        </p:txBody>
-      </p:sp>
-      <p:sp>
-        <p:nvSpPr>
-          <p:cNvPr id="5" name="Text 3"/>
+            <a:endParaRPr lang="en-US" sz="1800" dirty="0"/>
+          </a:p>
+        </p:txBody>
+      </p:sp>
+      <p:sp>
+        <p:nvSpPr>
+          <p:cNvPr id="7" name="Text 4"/>
           <p:cNvSpPr txBox="1"/>
           <p:nvPr/>
         </p:nvSpPr>
@@ -2044,16 +2124,40 @@
           <a:chExt cx="0" cy="0"/>
         </a:xfrm>
       </p:grpSpPr>
-      <p:sp>
-        <p:nvSpPr>
-          <p:cNvPr id="2" name="Text 0"/>
-          <p:cNvSpPr txBox="1"/>
-          <p:nvPr/>
-        </p:nvSpPr>
-        <p:spPr>
-          <a:xfrm>
-            <a:off x="548640" y="365760"/>
-            <a:ext cx="5486400" cy="274320"/>
+      <p:pic>
+        <p:nvPicPr>
+          <p:cNvPr id="2" name="Image 0" descr="logo_k.png">    </p:cNvPr>
+          <p:cNvPicPr>
+            <a:picLocks noChangeAspect="1"/>
+          </p:cNvPicPr>
+          <p:nvPr/>
+        </p:nvPicPr>
+        <p:blipFill>
+          <a:blip r:embed="rId1"/>
+          <a:stretch>
+            <a:fillRect/>
+          </a:stretch>
+        </p:blipFill>
+        <p:spPr>
+          <a:xfrm>
+            <a:off x="7726680" y="365760"/>
+            <a:ext cx="208905" cy="246888"/>
+          </a:xfrm>
+          <a:prstGeom prst="rect">
+            <a:avLst/>
+          </a:prstGeom>
+        </p:spPr>
+      </p:pic>
+      <p:sp>
+        <p:nvSpPr>
+          <p:cNvPr id="3" name="Text 0"/>
+          <p:cNvSpPr txBox="1"/>
+          <p:nvPr/>
+        </p:nvSpPr>
+        <p:spPr>
+          <a:xfrm>
+            <a:off x="8017881" y="347472"/>
+            <a:ext cx="1152144" cy="283464"/>
           </a:xfrm>
           <a:prstGeom prst="rect">
             <a:avLst/>
@@ -2069,14 +2173,53 @@
               <a:buNone/>
             </a:pPr>
             <a:r>
-              <a:rPr lang="en-US" sz="1100" b="1" spc="300" kern="0" dirty="0">
-                <a:solidFill>
-                  <a:srgbClr val="F26B1D"/>
+              <a:rPr lang="en-US" sz="1080" b="1" spc="400" kern="0" dirty="0">
+                <a:solidFill>
+                  <a:srgbClr val="111111"/>
                 </a:solidFill>
                 <a:latin typeface="Calibri" pitchFamily="34" charset="0"/>
                 <a:ea typeface="Calibri" pitchFamily="34" charset="-122"/>
                 <a:cs typeface="Calibri" pitchFamily="34" charset="-120"/>
               </a:rPr>
+              <a:t>PLUMB</a:t>
+            </a:r>
+            <a:endParaRPr lang="en-US" sz="1080" dirty="0"/>
+          </a:p>
+        </p:txBody>
+      </p:sp>
+      <p:sp>
+        <p:nvSpPr>
+          <p:cNvPr id="4" name="Text 1"/>
+          <p:cNvSpPr txBox="1"/>
+          <p:nvPr/>
+        </p:nvSpPr>
+        <p:spPr>
+          <a:xfrm>
+            <a:off x="548640" y="365760"/>
+            <a:ext cx="5486400" cy="274320"/>
+          </a:xfrm>
+          <a:prstGeom prst="rect">
+            <a:avLst/>
+          </a:prstGeom>
+          <a:noFill/>
+          <a:ln/>
+        </p:spPr>
+        <p:txBody>
+          <a:bodyPr wrap="square" lIns="0" tIns="0" rIns="0" bIns="0" rtlCol="0" anchor="ctr"/>
+          <a:lstStyle/>
+          <a:p>
+            <a:pPr indent="0" marL="0">
+              <a:buNone/>
+            </a:pPr>
+            <a:r>
+              <a:rPr lang="en-US" sz="1100" b="1" spc="300" kern="0" dirty="0">
+                <a:solidFill>
+                  <a:srgbClr val="F26B1D"/>
+                </a:solidFill>
+                <a:latin typeface="Calibri" pitchFamily="34" charset="0"/>
+                <a:ea typeface="Calibri" pitchFamily="34" charset="-122"/>
+                <a:cs typeface="Calibri" pitchFamily="34" charset="-120"/>
+              </a:rPr>
               <a:t>PROBLEM</a:t>
             </a:r>
             <a:endParaRPr lang="en-US" sz="1100" dirty="0"/>
@@ -2085,7 +2228,7 @@
       </p:sp>
       <p:sp>
         <p:nvSpPr>
-          <p:cNvPr id="3" name="Text 1"/>
+          <p:cNvPr id="5" name="Text 2"/>
           <p:cNvSpPr txBox="1"/>
           <p:nvPr/>
         </p:nvSpPr>
@@ -2124,7 +2267,7 @@
       </p:sp>
       <p:sp>
         <p:nvSpPr>
-          <p:cNvPr id="4" name="Shape 2"/>
+          <p:cNvPr id="6" name="Shape 3"/>
           <p:cNvSpPr/>
           <p:nvPr/>
         </p:nvSpPr>
@@ -2149,7 +2292,7 @@
       </p:sp>
       <p:sp>
         <p:nvSpPr>
-          <p:cNvPr id="5" name="Text 3"/>
+          <p:cNvPr id="7" name="Text 4"/>
           <p:cNvSpPr txBox="1"/>
           <p:nvPr/>
         </p:nvSpPr>
@@ -2188,7 +2331,7 @@
       </p:sp>
       <p:sp>
         <p:nvSpPr>
-          <p:cNvPr id="6" name="Text 4"/>
+          <p:cNvPr id="8" name="Text 5"/>
           <p:cNvSpPr txBox="1"/>
           <p:nvPr/>
         </p:nvSpPr>
@@ -2227,7 +2370,7 @@
       </p:sp>
       <p:sp>
         <p:nvSpPr>
-          <p:cNvPr id="7" name="Shape 5"/>
+          <p:cNvPr id="9" name="Shape 6"/>
           <p:cNvSpPr/>
           <p:nvPr/>
         </p:nvSpPr>
@@ -2252,7 +2395,7 @@
       </p:sp>
       <p:sp>
         <p:nvSpPr>
-          <p:cNvPr id="8" name="Text 6"/>
+          <p:cNvPr id="10" name="Text 7"/>
           <p:cNvSpPr txBox="1"/>
           <p:nvPr/>
         </p:nvSpPr>
@@ -2291,7 +2434,7 @@
       </p:sp>
       <p:sp>
         <p:nvSpPr>
-          <p:cNvPr id="9" name="Text 7"/>
+          <p:cNvPr id="11" name="Text 8"/>
           <p:cNvSpPr txBox="1"/>
           <p:nvPr/>
         </p:nvSpPr>
@@ -2330,7 +2473,7 @@
       </p:sp>
       <p:sp>
         <p:nvSpPr>
-          <p:cNvPr id="10" name="Shape 8"/>
+          <p:cNvPr id="12" name="Shape 9"/>
           <p:cNvSpPr/>
           <p:nvPr/>
         </p:nvSpPr>
@@ -2355,7 +2498,7 @@
       </p:sp>
       <p:sp>
         <p:nvSpPr>
-          <p:cNvPr id="11" name="Text 9"/>
+          <p:cNvPr id="13" name="Text 10"/>
           <p:cNvSpPr txBox="1"/>
           <p:nvPr/>
         </p:nvSpPr>
@@ -2394,7 +2537,7 @@
       </p:sp>
       <p:sp>
         <p:nvSpPr>
-          <p:cNvPr id="12" name="Text 10"/>
+          <p:cNvPr id="14" name="Text 11"/>
           <p:cNvSpPr txBox="1"/>
           <p:nvPr/>
         </p:nvSpPr>
@@ -2433,7 +2576,7 @@
       </p:sp>
       <p:sp>
         <p:nvSpPr>
-          <p:cNvPr id="13" name="Text 11"/>
+          <p:cNvPr id="15" name="Text 12"/>
           <p:cNvSpPr txBox="1"/>
           <p:nvPr/>
         </p:nvSpPr>
@@ -2502,16 +2645,40 @@
           <a:chExt cx="0" cy="0"/>
         </a:xfrm>
       </p:grpSpPr>
-      <p:sp>
-        <p:nvSpPr>
-          <p:cNvPr id="2" name="Text 0"/>
-          <p:cNvSpPr txBox="1"/>
-          <p:nvPr/>
-        </p:nvSpPr>
-        <p:spPr>
-          <a:xfrm>
-            <a:off x="548640" y="365760"/>
-            <a:ext cx="5486400" cy="274320"/>
+      <p:pic>
+        <p:nvPicPr>
+          <p:cNvPr id="2" name="Image 0" descr="logo_k.png">    </p:cNvPr>
+          <p:cNvPicPr>
+            <a:picLocks noChangeAspect="1"/>
+          </p:cNvPicPr>
+          <p:nvPr/>
+        </p:nvPicPr>
+        <p:blipFill>
+          <a:blip r:embed="rId1"/>
+          <a:stretch>
+            <a:fillRect/>
+          </a:stretch>
+        </p:blipFill>
+        <p:spPr>
+          <a:xfrm>
+            <a:off x="7726680" y="365760"/>
+            <a:ext cx="208905" cy="246888"/>
+          </a:xfrm>
+          <a:prstGeom prst="rect">
+            <a:avLst/>
+          </a:prstGeom>
+        </p:spPr>
+      </p:pic>
+      <p:sp>
+        <p:nvSpPr>
+          <p:cNvPr id="3" name="Text 0"/>
+          <p:cNvSpPr txBox="1"/>
+          <p:nvPr/>
+        </p:nvSpPr>
+        <p:spPr>
+          <a:xfrm>
+            <a:off x="8017881" y="347472"/>
+            <a:ext cx="1152144" cy="283464"/>
           </a:xfrm>
           <a:prstGeom prst="rect">
             <a:avLst/>
@@ -2527,14 +2694,53 @@
               <a:buNone/>
             </a:pPr>
             <a:r>
-              <a:rPr lang="en-US" sz="1100" b="1" spc="300" kern="0" dirty="0">
-                <a:solidFill>
-                  <a:srgbClr val="F26B1D"/>
+              <a:rPr lang="en-US" sz="1080" b="1" spc="400" kern="0" dirty="0">
+                <a:solidFill>
+                  <a:srgbClr val="111111"/>
                 </a:solidFill>
                 <a:latin typeface="Calibri" pitchFamily="34" charset="0"/>
                 <a:ea typeface="Calibri" pitchFamily="34" charset="-122"/>
                 <a:cs typeface="Calibri" pitchFamily="34" charset="-120"/>
               </a:rPr>
+              <a:t>PLUMB</a:t>
+            </a:r>
+            <a:endParaRPr lang="en-US" sz="1080" dirty="0"/>
+          </a:p>
+        </p:txBody>
+      </p:sp>
+      <p:sp>
+        <p:nvSpPr>
+          <p:cNvPr id="4" name="Text 1"/>
+          <p:cNvSpPr txBox="1"/>
+          <p:nvPr/>
+        </p:nvSpPr>
+        <p:spPr>
+          <a:xfrm>
+            <a:off x="548640" y="365760"/>
+            <a:ext cx="5486400" cy="274320"/>
+          </a:xfrm>
+          <a:prstGeom prst="rect">
+            <a:avLst/>
+          </a:prstGeom>
+          <a:noFill/>
+          <a:ln/>
+        </p:spPr>
+        <p:txBody>
+          <a:bodyPr wrap="square" lIns="0" tIns="0" rIns="0" bIns="0" rtlCol="0" anchor="ctr"/>
+          <a:lstStyle/>
+          <a:p>
+            <a:pPr indent="0" marL="0">
+              <a:buNone/>
+            </a:pPr>
+            <a:r>
+              <a:rPr lang="en-US" sz="1100" b="1" spc="300" kern="0" dirty="0">
+                <a:solidFill>
+                  <a:srgbClr val="F26B1D"/>
+                </a:solidFill>
+                <a:latin typeface="Calibri" pitchFamily="34" charset="0"/>
+                <a:ea typeface="Calibri" pitchFamily="34" charset="-122"/>
+                <a:cs typeface="Calibri" pitchFamily="34" charset="-120"/>
+              </a:rPr>
               <a:t>SOLUTION</a:t>
             </a:r>
             <a:endParaRPr lang="en-US" sz="1100" dirty="0"/>
@@ -2543,7 +2749,7 @@
       </p:sp>
       <p:sp>
         <p:nvSpPr>
-          <p:cNvPr id="3" name="Text 1"/>
+          <p:cNvPr id="5" name="Text 2"/>
           <p:cNvSpPr txBox="1"/>
           <p:nvPr/>
         </p:nvSpPr>
@@ -2582,7 +2788,7 @@
       </p:sp>
       <p:sp>
         <p:nvSpPr>
-          <p:cNvPr id="4" name="Shape 2"/>
+          <p:cNvPr id="6" name="Shape 3"/>
           <p:cNvSpPr/>
           <p:nvPr/>
         </p:nvSpPr>
@@ -2607,7 +2813,7 @@
       </p:sp>
       <p:sp>
         <p:nvSpPr>
-          <p:cNvPr id="5" name="Text 3"/>
+          <p:cNvPr id="7" name="Text 4"/>
           <p:cNvSpPr txBox="1"/>
           <p:nvPr/>
         </p:nvSpPr>
@@ -2646,7 +2852,7 @@
       </p:sp>
       <p:sp>
         <p:nvSpPr>
-          <p:cNvPr id="6" name="Text 4"/>
+          <p:cNvPr id="8" name="Text 5"/>
           <p:cNvSpPr txBox="1"/>
           <p:nvPr/>
         </p:nvSpPr>
@@ -2685,7 +2891,7 @@
       </p:sp>
       <p:sp>
         <p:nvSpPr>
-          <p:cNvPr id="7" name="Text 5"/>
+          <p:cNvPr id="9" name="Text 6"/>
           <p:cNvSpPr txBox="1"/>
           <p:nvPr/>
         </p:nvSpPr>
@@ -2724,7 +2930,7 @@
       </p:sp>
       <p:sp>
         <p:nvSpPr>
-          <p:cNvPr id="8" name="Shape 6"/>
+          <p:cNvPr id="10" name="Shape 7"/>
           <p:cNvSpPr/>
           <p:nvPr/>
         </p:nvSpPr>
@@ -2749,7 +2955,7 @@
       </p:sp>
       <p:sp>
         <p:nvSpPr>
-          <p:cNvPr id="9" name="Text 7"/>
+          <p:cNvPr id="11" name="Text 8"/>
           <p:cNvSpPr txBox="1"/>
           <p:nvPr/>
         </p:nvSpPr>
@@ -2788,7 +2994,7 @@
       </p:sp>
       <p:sp>
         <p:nvSpPr>
-          <p:cNvPr id="10" name="Text 8"/>
+          <p:cNvPr id="12" name="Text 9"/>
           <p:cNvSpPr txBox="1"/>
           <p:nvPr/>
         </p:nvSpPr>
@@ -2827,7 +3033,7 @@
       </p:sp>
       <p:sp>
         <p:nvSpPr>
-          <p:cNvPr id="11" name="Text 9"/>
+          <p:cNvPr id="13" name="Text 10"/>
           <p:cNvSpPr txBox="1"/>
           <p:nvPr/>
         </p:nvSpPr>
@@ -2866,7 +3072,7 @@
       </p:sp>
       <p:sp>
         <p:nvSpPr>
-          <p:cNvPr id="12" name="Shape 10"/>
+          <p:cNvPr id="14" name="Shape 11"/>
           <p:cNvSpPr/>
           <p:nvPr/>
         </p:nvSpPr>
@@ -2891,7 +3097,7 @@
       </p:sp>
       <p:sp>
         <p:nvSpPr>
-          <p:cNvPr id="13" name="Text 11"/>
+          <p:cNvPr id="15" name="Text 12"/>
           <p:cNvSpPr txBox="1"/>
           <p:nvPr/>
         </p:nvSpPr>
@@ -2930,7 +3136,7 @@
       </p:sp>
       <p:sp>
         <p:nvSpPr>
-          <p:cNvPr id="14" name="Text 12"/>
+          <p:cNvPr id="16" name="Text 13"/>
           <p:cNvSpPr txBox="1"/>
           <p:nvPr/>
         </p:nvSpPr>
@@ -2969,7 +3175,7 @@
       </p:sp>
       <p:sp>
         <p:nvSpPr>
-          <p:cNvPr id="15" name="Text 13"/>
+          <p:cNvPr id="17" name="Text 14"/>
           <p:cNvSpPr txBox="1"/>
           <p:nvPr/>
         </p:nvSpPr>
@@ -3038,87 +3244,9 @@
           <a:chExt cx="0" cy="0"/>
         </a:xfrm>
       </p:grpSpPr>
-      <p:sp>
-        <p:nvSpPr>
-          <p:cNvPr id="2" name="Text 0"/>
-          <p:cNvSpPr txBox="1"/>
-          <p:nvPr/>
-        </p:nvSpPr>
-        <p:spPr>
-          <a:xfrm>
-            <a:off x="548640" y="365760"/>
-            <a:ext cx="5486400" cy="274320"/>
-          </a:xfrm>
-          <a:prstGeom prst="rect">
-            <a:avLst/>
-          </a:prstGeom>
-          <a:noFill/>
-          <a:ln/>
-        </p:spPr>
-        <p:txBody>
-          <a:bodyPr wrap="square" lIns="0" tIns="0" rIns="0" bIns="0" rtlCol="0" anchor="ctr"/>
-          <a:lstStyle/>
-          <a:p>
-            <a:pPr indent="0" marL="0">
-              <a:buNone/>
-            </a:pPr>
-            <a:r>
-              <a:rPr lang="en-US" sz="1100" b="1" spc="300" kern="0" dirty="0">
-                <a:solidFill>
-                  <a:srgbClr val="F26B1D"/>
-                </a:solidFill>
-                <a:latin typeface="Calibri" pitchFamily="34" charset="0"/>
-                <a:ea typeface="Calibri" pitchFamily="34" charset="-122"/>
-                <a:cs typeface="Calibri" pitchFamily="34" charset="-120"/>
-              </a:rPr>
-              <a:t>PRODUCT DEMO</a:t>
-            </a:r>
-            <a:endParaRPr lang="en-US" sz="1100" dirty="0"/>
-          </a:p>
-        </p:txBody>
-      </p:sp>
-      <p:sp>
-        <p:nvSpPr>
-          <p:cNvPr id="3" name="Text 1"/>
-          <p:cNvSpPr txBox="1"/>
-          <p:nvPr/>
-        </p:nvSpPr>
-        <p:spPr>
-          <a:xfrm>
-            <a:off x="548640" y="658368"/>
-            <a:ext cx="8046720" cy="822960"/>
-          </a:xfrm>
-          <a:prstGeom prst="rect">
-            <a:avLst/>
-          </a:prstGeom>
-          <a:noFill/>
-          <a:ln/>
-        </p:spPr>
-        <p:txBody>
-          <a:bodyPr wrap="square" lIns="0" tIns="0" rIns="0" bIns="0" rtlCol="0" anchor="t"/>
-          <a:lstStyle/>
-          <a:p>
-            <a:pPr indent="0" marL="0">
-              <a:buNone/>
-            </a:pPr>
-            <a:r>
-              <a:rPr lang="en-US" sz="2600" b="1" dirty="0">
-                <a:solidFill>
-                  <a:srgbClr val="111111"/>
-                </a:solidFill>
-                <a:latin typeface="Georgia" pitchFamily="34" charset="0"/>
-                <a:ea typeface="Georgia" pitchFamily="34" charset="-122"/>
-                <a:cs typeface="Georgia" pitchFamily="34" charset="-120"/>
-              </a:rPr>
-              <a:t>A working web app and a clickable demo</a:t>
-            </a:r>
-            <a:endParaRPr lang="en-US" sz="2600" dirty="0"/>
-          </a:p>
-        </p:txBody>
-      </p:sp>
       <p:pic>
         <p:nvPicPr>
-          <p:cNvPr id="4" name="Image 0" descr="desk.png">    </p:cNvPr>
+          <p:cNvPr id="2" name="Image 0" descr="logo_k.png">    </p:cNvPr>
           <p:cNvPicPr>
             <a:picLocks noChangeAspect="1"/>
           </p:cNvPicPr>
@@ -3132,17 +3260,134 @@
         </p:blipFill>
         <p:spPr>
           <a:xfrm>
-            <a:off x="548640" y="1600200"/>
-            <a:ext cx="4023360" cy="2660904"/>
+            <a:off x="7726680" y="365760"/>
+            <a:ext cx="208905" cy="246888"/>
           </a:xfrm>
           <a:prstGeom prst="rect">
             <a:avLst/>
           </a:prstGeom>
         </p:spPr>
       </p:pic>
+      <p:sp>
+        <p:nvSpPr>
+          <p:cNvPr id="3" name="Text 0"/>
+          <p:cNvSpPr txBox="1"/>
+          <p:nvPr/>
+        </p:nvSpPr>
+        <p:spPr>
+          <a:xfrm>
+            <a:off x="8017881" y="347472"/>
+            <a:ext cx="1152144" cy="283464"/>
+          </a:xfrm>
+          <a:prstGeom prst="rect">
+            <a:avLst/>
+          </a:prstGeom>
+          <a:noFill/>
+          <a:ln/>
+        </p:spPr>
+        <p:txBody>
+          <a:bodyPr wrap="square" lIns="0" tIns="0" rIns="0" bIns="0" rtlCol="0" anchor="ctr"/>
+          <a:lstStyle/>
+          <a:p>
+            <a:pPr indent="0" marL="0">
+              <a:buNone/>
+            </a:pPr>
+            <a:r>
+              <a:rPr lang="en-US" sz="1080" b="1" spc="400" kern="0" dirty="0">
+                <a:solidFill>
+                  <a:srgbClr val="111111"/>
+                </a:solidFill>
+                <a:latin typeface="Calibri" pitchFamily="34" charset="0"/>
+                <a:ea typeface="Calibri" pitchFamily="34" charset="-122"/>
+                <a:cs typeface="Calibri" pitchFamily="34" charset="-120"/>
+              </a:rPr>
+              <a:t>PLUMB</a:t>
+            </a:r>
+            <a:endParaRPr lang="en-US" sz="1080" dirty="0"/>
+          </a:p>
+        </p:txBody>
+      </p:sp>
+      <p:sp>
+        <p:nvSpPr>
+          <p:cNvPr id="4" name="Text 1"/>
+          <p:cNvSpPr txBox="1"/>
+          <p:nvPr/>
+        </p:nvSpPr>
+        <p:spPr>
+          <a:xfrm>
+            <a:off x="548640" y="365760"/>
+            <a:ext cx="5486400" cy="274320"/>
+          </a:xfrm>
+          <a:prstGeom prst="rect">
+            <a:avLst/>
+          </a:prstGeom>
+          <a:noFill/>
+          <a:ln/>
+        </p:spPr>
+        <p:txBody>
+          <a:bodyPr wrap="square" lIns="0" tIns="0" rIns="0" bIns="0" rtlCol="0" anchor="ctr"/>
+          <a:lstStyle/>
+          <a:p>
+            <a:pPr indent="0" marL="0">
+              <a:buNone/>
+            </a:pPr>
+            <a:r>
+              <a:rPr lang="en-US" sz="1100" b="1" spc="300" kern="0" dirty="0">
+                <a:solidFill>
+                  <a:srgbClr val="F26B1D"/>
+                </a:solidFill>
+                <a:latin typeface="Calibri" pitchFamily="34" charset="0"/>
+                <a:ea typeface="Calibri" pitchFamily="34" charset="-122"/>
+                <a:cs typeface="Calibri" pitchFamily="34" charset="-120"/>
+              </a:rPr>
+              <a:t>PRODUCT DEMO</a:t>
+            </a:r>
+            <a:endParaRPr lang="en-US" sz="1100" dirty="0"/>
+          </a:p>
+        </p:txBody>
+      </p:sp>
+      <p:sp>
+        <p:nvSpPr>
+          <p:cNvPr id="5" name="Text 2"/>
+          <p:cNvSpPr txBox="1"/>
+          <p:nvPr/>
+        </p:nvSpPr>
+        <p:spPr>
+          <a:xfrm>
+            <a:off x="548640" y="658368"/>
+            <a:ext cx="8046720" cy="822960"/>
+          </a:xfrm>
+          <a:prstGeom prst="rect">
+            <a:avLst/>
+          </a:prstGeom>
+          <a:noFill/>
+          <a:ln/>
+        </p:spPr>
+        <p:txBody>
+          <a:bodyPr wrap="square" lIns="0" tIns="0" rIns="0" bIns="0" rtlCol="0" anchor="t"/>
+          <a:lstStyle/>
+          <a:p>
+            <a:pPr indent="0" marL="0">
+              <a:buNone/>
+            </a:pPr>
+            <a:r>
+              <a:rPr lang="en-US" sz="2600" b="1" dirty="0">
+                <a:solidFill>
+                  <a:srgbClr val="111111"/>
+                </a:solidFill>
+                <a:latin typeface="Georgia" pitchFamily="34" charset="0"/>
+                <a:ea typeface="Georgia" pitchFamily="34" charset="-122"/>
+                <a:cs typeface="Georgia" pitchFamily="34" charset="-120"/>
+              </a:rPr>
+              <a:t>A working web app and a clickable demo</a:t>
+            </a:r>
+            <a:endParaRPr lang="en-US" sz="2600" dirty="0"/>
+          </a:p>
+        </p:txBody>
+      </p:sp>
       <p:pic>
         <p:nvPicPr>
-          <p:cNvPr id="5" name="Image 1" descr="app.png">    </p:cNvPr>
+          <p:cNvPr id="6" name="Image 1" descr="desk.png">    </p:cNvPr>
           <p:cNvPicPr>
             <a:picLocks noChangeAspect="1"/>
           </p:cNvPicPr>
@@ -3156,6 +3401,30 @@
         </p:blipFill>
         <p:spPr>
           <a:xfrm>
+            <a:off x="548640" y="1600200"/>
+            <a:ext cx="4023360" cy="2660904"/>
+          </a:xfrm>
+          <a:prstGeom prst="rect">
+            <a:avLst/>
+          </a:prstGeom>
+        </p:spPr>
+      </p:pic>
+      <p:pic>
+        <p:nvPicPr>
+          <p:cNvPr id="7" name="Image 2" descr="app.png">    </p:cNvPr>
+          <p:cNvPicPr>
+            <a:picLocks noChangeAspect="1"/>
+          </p:cNvPicPr>
+          <p:nvPr/>
+        </p:nvPicPr>
+        <p:blipFill>
+          <a:blip r:embed="rId3"/>
+          <a:stretch>
+            <a:fillRect/>
+          </a:stretch>
+        </p:blipFill>
+        <p:spPr>
+          <a:xfrm>
             <a:off x="4709160" y="1600200"/>
             <a:ext cx="3886200" cy="2423160"/>
           </a:xfrm>
@@ -3166,7 +3435,7 @@
       </p:pic>
       <p:sp>
         <p:nvSpPr>
-          <p:cNvPr id="6" name="Text 2"/>
+          <p:cNvPr id="8" name="Text 3"/>
           <p:cNvSpPr txBox="1"/>
           <p:nvPr/>
         </p:nvSpPr>
@@ -3205,7 +3474,7 @@
       </p:sp>
       <p:sp>
         <p:nvSpPr>
-          <p:cNvPr id="7" name="Text 3"/>
+          <p:cNvPr id="9" name="Text 4"/>
           <p:cNvSpPr txBox="1"/>
           <p:nvPr/>
         </p:nvSpPr>
@@ -3244,7 +3513,7 @@
       </p:sp>
       <p:sp>
         <p:nvSpPr>
-          <p:cNvPr id="8" name="Text 4"/>
+          <p:cNvPr id="10" name="Text 5"/>
           <p:cNvSpPr txBox="1"/>
           <p:nvPr/>
         </p:nvSpPr>
@@ -3313,16 +3582,40 @@
           <a:chExt cx="0" cy="0"/>
         </a:xfrm>
       </p:grpSpPr>
-      <p:sp>
-        <p:nvSpPr>
-          <p:cNvPr id="2" name="Text 0"/>
-          <p:cNvSpPr txBox="1"/>
-          <p:nvPr/>
-        </p:nvSpPr>
-        <p:spPr>
-          <a:xfrm>
-            <a:off x="548640" y="365760"/>
-            <a:ext cx="5486400" cy="274320"/>
+      <p:pic>
+        <p:nvPicPr>
+          <p:cNvPr id="2" name="Image 0" descr="logo_k.png">    </p:cNvPr>
+          <p:cNvPicPr>
+            <a:picLocks noChangeAspect="1"/>
+          </p:cNvPicPr>
+          <p:nvPr/>
+        </p:nvPicPr>
+        <p:blipFill>
+          <a:blip r:embed="rId1"/>
+          <a:stretch>
+            <a:fillRect/>
+          </a:stretch>
+        </p:blipFill>
+        <p:spPr>
+          <a:xfrm>
+            <a:off x="7726680" y="365760"/>
+            <a:ext cx="208905" cy="246888"/>
+          </a:xfrm>
+          <a:prstGeom prst="rect">
+            <a:avLst/>
+          </a:prstGeom>
+        </p:spPr>
+      </p:pic>
+      <p:sp>
+        <p:nvSpPr>
+          <p:cNvPr id="3" name="Text 0"/>
+          <p:cNvSpPr txBox="1"/>
+          <p:nvPr/>
+        </p:nvSpPr>
+        <p:spPr>
+          <a:xfrm>
+            <a:off x="8017881" y="347472"/>
+            <a:ext cx="1152144" cy="283464"/>
           </a:xfrm>
           <a:prstGeom prst="rect">
             <a:avLst/>
@@ -3338,14 +3631,53 @@
               <a:buNone/>
             </a:pPr>
             <a:r>
-              <a:rPr lang="en-US" sz="1100" b="1" spc="300" kern="0" dirty="0">
-                <a:solidFill>
-                  <a:srgbClr val="F26B1D"/>
+              <a:rPr lang="en-US" sz="1080" b="1" spc="400" kern="0" dirty="0">
+                <a:solidFill>
+                  <a:srgbClr val="111111"/>
                 </a:solidFill>
                 <a:latin typeface="Calibri" pitchFamily="34" charset="0"/>
                 <a:ea typeface="Calibri" pitchFamily="34" charset="-122"/>
                 <a:cs typeface="Calibri" pitchFamily="34" charset="-120"/>
               </a:rPr>
+              <a:t>PLUMB</a:t>
+            </a:r>
+            <a:endParaRPr lang="en-US" sz="1080" dirty="0"/>
+          </a:p>
+        </p:txBody>
+      </p:sp>
+      <p:sp>
+        <p:nvSpPr>
+          <p:cNvPr id="4" name="Text 1"/>
+          <p:cNvSpPr txBox="1"/>
+          <p:nvPr/>
+        </p:nvSpPr>
+        <p:spPr>
+          <a:xfrm>
+            <a:off x="548640" y="365760"/>
+            <a:ext cx="5486400" cy="274320"/>
+          </a:xfrm>
+          <a:prstGeom prst="rect">
+            <a:avLst/>
+          </a:prstGeom>
+          <a:noFill/>
+          <a:ln/>
+        </p:spPr>
+        <p:txBody>
+          <a:bodyPr wrap="square" lIns="0" tIns="0" rIns="0" bIns="0" rtlCol="0" anchor="ctr"/>
+          <a:lstStyle/>
+          <a:p>
+            <a:pPr indent="0" marL="0">
+              <a:buNone/>
+            </a:pPr>
+            <a:r>
+              <a:rPr lang="en-US" sz="1100" b="1" spc="300" kern="0" dirty="0">
+                <a:solidFill>
+                  <a:srgbClr val="F26B1D"/>
+                </a:solidFill>
+                <a:latin typeface="Calibri" pitchFamily="34" charset="0"/>
+                <a:ea typeface="Calibri" pitchFamily="34" charset="-122"/>
+                <a:cs typeface="Calibri" pitchFamily="34" charset="-120"/>
+              </a:rPr>
               <a:t>TRACTION</a:t>
             </a:r>
             <a:endParaRPr lang="en-US" sz="1100" dirty="0"/>
@@ -3354,7 +3686,7 @@
       </p:sp>
       <p:sp>
         <p:nvSpPr>
-          <p:cNvPr id="3" name="Text 1"/>
+          <p:cNvPr id="5" name="Text 2"/>
           <p:cNvSpPr txBox="1"/>
           <p:nvPr/>
         </p:nvSpPr>
@@ -3393,7 +3725,7 @@
       </p:sp>
       <p:sp>
         <p:nvSpPr>
-          <p:cNvPr id="4" name="Text 2"/>
+          <p:cNvPr id="6" name="Text 3"/>
           <p:cNvSpPr txBox="1"/>
           <p:nvPr/>
         </p:nvSpPr>
@@ -3432,7 +3764,7 @@
       </p:sp>
       <p:sp>
         <p:nvSpPr>
-          <p:cNvPr id="5" name="Text 3"/>
+          <p:cNvPr id="7" name="Text 4"/>
           <p:cNvSpPr txBox="1"/>
           <p:nvPr/>
         </p:nvSpPr>
@@ -3471,7 +3803,7 @@
       </p:sp>
       <p:sp>
         <p:nvSpPr>
-          <p:cNvPr id="6" name="Text 4"/>
+          <p:cNvPr id="8" name="Text 5"/>
           <p:cNvSpPr txBox="1"/>
           <p:nvPr/>
         </p:nvSpPr>
@@ -3510,7 +3842,7 @@
       </p:sp>
       <p:sp>
         <p:nvSpPr>
-          <p:cNvPr id="7" name="Text 5"/>
+          <p:cNvPr id="9" name="Text 6"/>
           <p:cNvSpPr txBox="1"/>
           <p:nvPr/>
         </p:nvSpPr>
@@ -3549,7 +3881,7 @@
       </p:sp>
       <p:sp>
         <p:nvSpPr>
-          <p:cNvPr id="8" name="Text 6"/>
+          <p:cNvPr id="10" name="Text 7"/>
           <p:cNvSpPr txBox="1"/>
           <p:nvPr/>
         </p:nvSpPr>
@@ -3588,7 +3920,7 @@
       </p:sp>
       <p:sp>
         <p:nvSpPr>
-          <p:cNvPr id="9" name="Text 7"/>
+          <p:cNvPr id="11" name="Text 8"/>
           <p:cNvSpPr txBox="1"/>
           <p:nvPr/>
         </p:nvSpPr>
@@ -3627,7 +3959,7 @@
       </p:sp>
       <p:sp>
         <p:nvSpPr>
-          <p:cNvPr id="10" name="Text 8"/>
+          <p:cNvPr id="12" name="Text 9"/>
           <p:cNvSpPr txBox="1"/>
           <p:nvPr/>
         </p:nvSpPr>
@@ -3666,7 +3998,7 @@
       </p:sp>
       <p:sp>
         <p:nvSpPr>
-          <p:cNvPr id="11" name="Text 9"/>
+          <p:cNvPr id="13" name="Text 10"/>
           <p:cNvSpPr txBox="1"/>
           <p:nvPr/>
         </p:nvSpPr>
@@ -3705,7 +4037,7 @@
       </p:sp>
       <p:sp>
         <p:nvSpPr>
-          <p:cNvPr id="12" name="Text 10"/>
+          <p:cNvPr id="14" name="Text 11"/>
           <p:cNvSpPr txBox="1"/>
           <p:nvPr/>
         </p:nvSpPr>
@@ -3774,16 +4106,40 @@
           <a:chExt cx="0" cy="0"/>
         </a:xfrm>
       </p:grpSpPr>
-      <p:sp>
-        <p:nvSpPr>
-          <p:cNvPr id="2" name="Text 0"/>
-          <p:cNvSpPr txBox="1"/>
-          <p:nvPr/>
-        </p:nvSpPr>
-        <p:spPr>
-          <a:xfrm>
-            <a:off x="548640" y="365760"/>
-            <a:ext cx="5486400" cy="274320"/>
+      <p:pic>
+        <p:nvPicPr>
+          <p:cNvPr id="2" name="Image 0" descr="logo_k.png">    </p:cNvPr>
+          <p:cNvPicPr>
+            <a:picLocks noChangeAspect="1"/>
+          </p:cNvPicPr>
+          <p:nvPr/>
+        </p:nvPicPr>
+        <p:blipFill>
+          <a:blip r:embed="rId1"/>
+          <a:stretch>
+            <a:fillRect/>
+          </a:stretch>
+        </p:blipFill>
+        <p:spPr>
+          <a:xfrm>
+            <a:off x="7726680" y="365760"/>
+            <a:ext cx="208905" cy="246888"/>
+          </a:xfrm>
+          <a:prstGeom prst="rect">
+            <a:avLst/>
+          </a:prstGeom>
+        </p:spPr>
+      </p:pic>
+      <p:sp>
+        <p:nvSpPr>
+          <p:cNvPr id="3" name="Text 0"/>
+          <p:cNvSpPr txBox="1"/>
+          <p:nvPr/>
+        </p:nvSpPr>
+        <p:spPr>
+          <a:xfrm>
+            <a:off x="8017881" y="347472"/>
+            <a:ext cx="1152144" cy="283464"/>
           </a:xfrm>
           <a:prstGeom prst="rect">
             <a:avLst/>
@@ -3799,14 +4155,53 @@
               <a:buNone/>
             </a:pPr>
             <a:r>
-              <a:rPr lang="en-US" sz="1100" b="1" spc="300" kern="0" dirty="0">
-                <a:solidFill>
-                  <a:srgbClr val="F26B1D"/>
+              <a:rPr lang="en-US" sz="1080" b="1" spc="400" kern="0" dirty="0">
+                <a:solidFill>
+                  <a:srgbClr val="111111"/>
                 </a:solidFill>
                 <a:latin typeface="Calibri" pitchFamily="34" charset="0"/>
                 <a:ea typeface="Calibri" pitchFamily="34" charset="-122"/>
                 <a:cs typeface="Calibri" pitchFamily="34" charset="-120"/>
               </a:rPr>
+              <a:t>PLUMB</a:t>
+            </a:r>
+            <a:endParaRPr lang="en-US" sz="1080" dirty="0"/>
+          </a:p>
+        </p:txBody>
+      </p:sp>
+      <p:sp>
+        <p:nvSpPr>
+          <p:cNvPr id="4" name="Text 1"/>
+          <p:cNvSpPr txBox="1"/>
+          <p:nvPr/>
+        </p:nvSpPr>
+        <p:spPr>
+          <a:xfrm>
+            <a:off x="548640" y="365760"/>
+            <a:ext cx="5486400" cy="274320"/>
+          </a:xfrm>
+          <a:prstGeom prst="rect">
+            <a:avLst/>
+          </a:prstGeom>
+          <a:noFill/>
+          <a:ln/>
+        </p:spPr>
+        <p:txBody>
+          <a:bodyPr wrap="square" lIns="0" tIns="0" rIns="0" bIns="0" rtlCol="0" anchor="ctr"/>
+          <a:lstStyle/>
+          <a:p>
+            <a:pPr indent="0" marL="0">
+              <a:buNone/>
+            </a:pPr>
+            <a:r>
+              <a:rPr lang="en-US" sz="1100" b="1" spc="300" kern="0" dirty="0">
+                <a:solidFill>
+                  <a:srgbClr val="F26B1D"/>
+                </a:solidFill>
+                <a:latin typeface="Calibri" pitchFamily="34" charset="0"/>
+                <a:ea typeface="Calibri" pitchFamily="34" charset="-122"/>
+                <a:cs typeface="Calibri" pitchFamily="34" charset="-120"/>
+              </a:rPr>
               <a:t>RESULTS ON SAMPLE DATA</a:t>
             </a:r>
             <a:endParaRPr lang="en-US" sz="1100" dirty="0"/>
@@ -3815,7 +4210,7 @@
       </p:sp>
       <p:sp>
         <p:nvSpPr>
-          <p:cNvPr id="3" name="Text 1"/>
+          <p:cNvPr id="5" name="Text 2"/>
           <p:cNvSpPr txBox="1"/>
           <p:nvPr/>
         </p:nvSpPr>
@@ -3854,7 +4249,7 @@
       </p:sp>
       <p:graphicFrame>
         <p:nvGraphicFramePr>
-          <p:cNvPr id="4" name="Chart 0" descr=""/>
+          <p:cNvPr id="6" name="Chart 0" descr=""/>
           <p:cNvGraphicFramePr/>
           <p:nvPr/>
         </p:nvGraphicFramePr>
@@ -3864,13 +4259,13 @@
         </p:xfrm>
         <a:graphic xmlns:a="http://schemas.openxmlformats.org/drawingml/2006/main">
           <a:graphicData uri="http://schemas.openxmlformats.org/drawingml/2006/chart">
-            <c:chart xmlns:c="http://schemas.openxmlformats.org/drawingml/2006/chart" r:id="rId1"/>
+            <c:chart xmlns:c="http://schemas.openxmlformats.org/drawingml/2006/chart" r:id="rId2"/>
           </a:graphicData>
         </a:graphic>
       </p:graphicFrame>
       <p:sp>
         <p:nvSpPr>
-          <p:cNvPr id="5" name="Text 2"/>
+          <p:cNvPr id="7" name="Text 3"/>
           <p:cNvSpPr txBox="1"/>
           <p:nvPr/>
         </p:nvSpPr>
@@ -4022,16 +4417,40 @@
           <a:chExt cx="0" cy="0"/>
         </a:xfrm>
       </p:grpSpPr>
-      <p:sp>
-        <p:nvSpPr>
-          <p:cNvPr id="2" name="Text 0"/>
-          <p:cNvSpPr txBox="1"/>
-          <p:nvPr/>
-        </p:nvSpPr>
-        <p:spPr>
-          <a:xfrm>
-            <a:off x="548640" y="365760"/>
-            <a:ext cx="5486400" cy="274320"/>
+      <p:pic>
+        <p:nvPicPr>
+          <p:cNvPr id="2" name="Image 0" descr="logo_k.png">    </p:cNvPr>
+          <p:cNvPicPr>
+            <a:picLocks noChangeAspect="1"/>
+          </p:cNvPicPr>
+          <p:nvPr/>
+        </p:nvPicPr>
+        <p:blipFill>
+          <a:blip r:embed="rId1"/>
+          <a:stretch>
+            <a:fillRect/>
+          </a:stretch>
+        </p:blipFill>
+        <p:spPr>
+          <a:xfrm>
+            <a:off x="7726680" y="365760"/>
+            <a:ext cx="208905" cy="246888"/>
+          </a:xfrm>
+          <a:prstGeom prst="rect">
+            <a:avLst/>
+          </a:prstGeom>
+        </p:spPr>
+      </p:pic>
+      <p:sp>
+        <p:nvSpPr>
+          <p:cNvPr id="3" name="Text 0"/>
+          <p:cNvSpPr txBox="1"/>
+          <p:nvPr/>
+        </p:nvSpPr>
+        <p:spPr>
+          <a:xfrm>
+            <a:off x="8017881" y="347472"/>
+            <a:ext cx="1152144" cy="283464"/>
           </a:xfrm>
           <a:prstGeom prst="rect">
             <a:avLst/>
@@ -4047,14 +4466,53 @@
               <a:buNone/>
             </a:pPr>
             <a:r>
-              <a:rPr lang="en-US" sz="1100" b="1" spc="300" kern="0" dirty="0">
-                <a:solidFill>
-                  <a:srgbClr val="F26B1D"/>
+              <a:rPr lang="en-US" sz="1080" b="1" spc="400" kern="0" dirty="0">
+                <a:solidFill>
+                  <a:srgbClr val="111111"/>
                 </a:solidFill>
                 <a:latin typeface="Calibri" pitchFamily="34" charset="0"/>
                 <a:ea typeface="Calibri" pitchFamily="34" charset="-122"/>
                 <a:cs typeface="Calibri" pitchFamily="34" charset="-120"/>
               </a:rPr>
+              <a:t>PLUMB</a:t>
+            </a:r>
+            <a:endParaRPr lang="en-US" sz="1080" dirty="0"/>
+          </a:p>
+        </p:txBody>
+      </p:sp>
+      <p:sp>
+        <p:nvSpPr>
+          <p:cNvPr id="4" name="Text 1"/>
+          <p:cNvSpPr txBox="1"/>
+          <p:nvPr/>
+        </p:nvSpPr>
+        <p:spPr>
+          <a:xfrm>
+            <a:off x="548640" y="365760"/>
+            <a:ext cx="5486400" cy="274320"/>
+          </a:xfrm>
+          <a:prstGeom prst="rect">
+            <a:avLst/>
+          </a:prstGeom>
+          <a:noFill/>
+          <a:ln/>
+        </p:spPr>
+        <p:txBody>
+          <a:bodyPr wrap="square" lIns="0" tIns="0" rIns="0" bIns="0" rtlCol="0" anchor="ctr"/>
+          <a:lstStyle/>
+          <a:p>
+            <a:pPr indent="0" marL="0">
+              <a:buNone/>
+            </a:pPr>
+            <a:r>
+              <a:rPr lang="en-US" sz="1100" b="1" spc="300" kern="0" dirty="0">
+                <a:solidFill>
+                  <a:srgbClr val="F26B1D"/>
+                </a:solidFill>
+                <a:latin typeface="Calibri" pitchFamily="34" charset="0"/>
+                <a:ea typeface="Calibri" pitchFamily="34" charset="-122"/>
+                <a:cs typeface="Calibri" pitchFamily="34" charset="-120"/>
+              </a:rPr>
               <a:t>BUILD JOURNEY</a:t>
             </a:r>
             <a:endParaRPr lang="en-US" sz="1100" dirty="0"/>
@@ -4063,7 +4521,7 @@
       </p:sp>
       <p:sp>
         <p:nvSpPr>
-          <p:cNvPr id="3" name="Text 1"/>
+          <p:cNvPr id="5" name="Text 2"/>
           <p:cNvSpPr txBox="1"/>
           <p:nvPr/>
         </p:nvSpPr>
@@ -4102,7 +4560,7 @@
       </p:sp>
       <p:sp>
         <p:nvSpPr>
-          <p:cNvPr id="4" name="Text 2"/>
+          <p:cNvPr id="6" name="Text 3"/>
           <p:cNvSpPr txBox="1"/>
           <p:nvPr/>
         </p:nvSpPr>
@@ -4141,7 +4599,7 @@
       </p:sp>
       <p:sp>
         <p:nvSpPr>
-          <p:cNvPr id="5" name="Text 3"/>
+          <p:cNvPr id="7" name="Text 4"/>
           <p:cNvSpPr txBox="1"/>
           <p:nvPr/>
         </p:nvSpPr>
@@ -4180,7 +4638,7 @@
       </p:sp>
       <p:sp>
         <p:nvSpPr>
-          <p:cNvPr id="6" name="Shape 4"/>
+          <p:cNvPr id="8" name="Shape 5"/>
           <p:cNvSpPr/>
           <p:nvPr/>
         </p:nvSpPr>
@@ -4203,7 +4661,7 @@
       </p:sp>
       <p:sp>
         <p:nvSpPr>
-          <p:cNvPr id="7" name="Text 5"/>
+          <p:cNvPr id="9" name="Text 6"/>
           <p:cNvSpPr txBox="1"/>
           <p:nvPr/>
         </p:nvSpPr>
@@ -4242,7 +4700,7 @@
       </p:sp>
       <p:sp>
         <p:nvSpPr>
-          <p:cNvPr id="8" name="Text 6"/>
+          <p:cNvPr id="10" name="Text 7"/>
           <p:cNvSpPr txBox="1"/>
           <p:nvPr/>
         </p:nvSpPr>
@@ -4281,7 +4739,7 @@
       </p:sp>
       <p:sp>
         <p:nvSpPr>
-          <p:cNvPr id="9" name="Shape 7"/>
+          <p:cNvPr id="11" name="Shape 8"/>
           <p:cNvSpPr/>
           <p:nvPr/>
         </p:nvSpPr>
@@ -4304,7 +4762,7 @@
       </p:sp>
       <p:sp>
         <p:nvSpPr>
-          <p:cNvPr id="10" name="Text 8"/>
+          <p:cNvPr id="12" name="Text 9"/>
           <p:cNvSpPr txBox="1"/>
           <p:nvPr/>
         </p:nvSpPr>
@@ -4343,7 +4801,7 @@
       </p:sp>
       <p:sp>
         <p:nvSpPr>
-          <p:cNvPr id="11" name="Text 9"/>
+          <p:cNvPr id="13" name="Text 10"/>
           <p:cNvSpPr txBox="1"/>
           <p:nvPr/>
         </p:nvSpPr>
@@ -4382,7 +4840,7 @@
       </p:sp>
       <p:sp>
         <p:nvSpPr>
-          <p:cNvPr id="12" name="Shape 10"/>
+          <p:cNvPr id="14" name="Shape 11"/>
           <p:cNvSpPr/>
           <p:nvPr/>
         </p:nvSpPr>
@@ -4405,7 +4863,7 @@
       </p:sp>
       <p:sp>
         <p:nvSpPr>
-          <p:cNvPr id="13" name="Text 11"/>
+          <p:cNvPr id="15" name="Text 12"/>
           <p:cNvSpPr txBox="1"/>
           <p:nvPr/>
         </p:nvSpPr>
@@ -4444,7 +4902,7 @@
       </p:sp>
       <p:sp>
         <p:nvSpPr>
-          <p:cNvPr id="14" name="Text 12"/>
+          <p:cNvPr id="16" name="Text 13"/>
           <p:cNvSpPr txBox="1"/>
           <p:nvPr/>
         </p:nvSpPr>
@@ -4483,7 +4941,7 @@
       </p:sp>
       <p:sp>
         <p:nvSpPr>
-          <p:cNvPr id="15" name="Shape 13"/>
+          <p:cNvPr id="17" name="Shape 14"/>
           <p:cNvSpPr/>
           <p:nvPr/>
         </p:nvSpPr>
@@ -4506,7 +4964,7 @@
       </p:sp>
       <p:sp>
         <p:nvSpPr>
-          <p:cNvPr id="16" name="Text 14"/>
+          <p:cNvPr id="18" name="Text 15"/>
           <p:cNvSpPr txBox="1"/>
           <p:nvPr/>
         </p:nvSpPr>
@@ -4545,7 +5003,7 @@
       </p:sp>
       <p:sp>
         <p:nvSpPr>
-          <p:cNvPr id="17" name="Text 15"/>
+          <p:cNvPr id="19" name="Text 16"/>
           <p:cNvSpPr txBox="1"/>
           <p:nvPr/>
         </p:nvSpPr>
@@ -4614,16 +5072,40 @@
           <a:chExt cx="0" cy="0"/>
         </a:xfrm>
       </p:grpSpPr>
-      <p:sp>
-        <p:nvSpPr>
-          <p:cNvPr id="2" name="Text 0"/>
-          <p:cNvSpPr txBox="1"/>
-          <p:nvPr/>
-        </p:nvSpPr>
-        <p:spPr>
-          <a:xfrm>
-            <a:off x="548640" y="365760"/>
-            <a:ext cx="5486400" cy="274320"/>
+      <p:pic>
+        <p:nvPicPr>
+          <p:cNvPr id="2" name="Image 0" descr="logo_k.png">    </p:cNvPr>
+          <p:cNvPicPr>
+            <a:picLocks noChangeAspect="1"/>
+          </p:cNvPicPr>
+          <p:nvPr/>
+        </p:nvPicPr>
+        <p:blipFill>
+          <a:blip r:embed="rId1"/>
+          <a:stretch>
+            <a:fillRect/>
+          </a:stretch>
+        </p:blipFill>
+        <p:spPr>
+          <a:xfrm>
+            <a:off x="7726680" y="365760"/>
+            <a:ext cx="208905" cy="246888"/>
+          </a:xfrm>
+          <a:prstGeom prst="rect">
+            <a:avLst/>
+          </a:prstGeom>
+        </p:spPr>
+      </p:pic>
+      <p:sp>
+        <p:nvSpPr>
+          <p:cNvPr id="3" name="Text 0"/>
+          <p:cNvSpPr txBox="1"/>
+          <p:nvPr/>
+        </p:nvSpPr>
+        <p:spPr>
+          <a:xfrm>
+            <a:off x="8017881" y="347472"/>
+            <a:ext cx="1152144" cy="283464"/>
           </a:xfrm>
           <a:prstGeom prst="rect">
             <a:avLst/>
@@ -4639,14 +5121,53 @@
               <a:buNone/>
             </a:pPr>
             <a:r>
-              <a:rPr lang="en-US" sz="1100" b="1" spc="300" kern="0" dirty="0">
-                <a:solidFill>
-                  <a:srgbClr val="F26B1D"/>
+              <a:rPr lang="en-US" sz="1080" b="1" spc="400" kern="0" dirty="0">
+                <a:solidFill>
+                  <a:srgbClr val="111111"/>
                 </a:solidFill>
                 <a:latin typeface="Calibri" pitchFamily="34" charset="0"/>
                 <a:ea typeface="Calibri" pitchFamily="34" charset="-122"/>
                 <a:cs typeface="Calibri" pitchFamily="34" charset="-120"/>
               </a:rPr>
+              <a:t>PLUMB</a:t>
+            </a:r>
+            <a:endParaRPr lang="en-US" sz="1080" dirty="0"/>
+          </a:p>
+        </p:txBody>
+      </p:sp>
+      <p:sp>
+        <p:nvSpPr>
+          <p:cNvPr id="4" name="Text 1"/>
+          <p:cNvSpPr txBox="1"/>
+          <p:nvPr/>
+        </p:nvSpPr>
+        <p:spPr>
+          <a:xfrm>
+            <a:off x="548640" y="365760"/>
+            <a:ext cx="5486400" cy="274320"/>
+          </a:xfrm>
+          <a:prstGeom prst="rect">
+            <a:avLst/>
+          </a:prstGeom>
+          <a:noFill/>
+          <a:ln/>
+        </p:spPr>
+        <p:txBody>
+          <a:bodyPr wrap="square" lIns="0" tIns="0" rIns="0" bIns="0" rtlCol="0" anchor="ctr"/>
+          <a:lstStyle/>
+          <a:p>
+            <a:pPr indent="0" marL="0">
+              <a:buNone/>
+            </a:pPr>
+            <a:r>
+              <a:rPr lang="en-US" sz="1100" b="1" spc="300" kern="0" dirty="0">
+                <a:solidFill>
+                  <a:srgbClr val="F26B1D"/>
+                </a:solidFill>
+                <a:latin typeface="Calibri" pitchFamily="34" charset="0"/>
+                <a:ea typeface="Calibri" pitchFamily="34" charset="-122"/>
+                <a:cs typeface="Calibri" pitchFamily="34" charset="-120"/>
+              </a:rPr>
               <a:t>TEAM</a:t>
             </a:r>
             <a:endParaRPr lang="en-US" sz="1100" dirty="0"/>
@@ -4655,7 +5176,7 @@
       </p:sp>
       <p:sp>
         <p:nvSpPr>
-          <p:cNvPr id="3" name="Text 1"/>
+          <p:cNvPr id="5" name="Text 2"/>
           <p:cNvSpPr txBox="1"/>
           <p:nvPr/>
         </p:nvSpPr>
@@ -4694,7 +5215,7 @@
       </p:sp>
       <p:sp>
         <p:nvSpPr>
-          <p:cNvPr id="4" name="Text 2"/>
+          <p:cNvPr id="6" name="Text 3"/>
           <p:cNvSpPr txBox="1"/>
           <p:nvPr/>
         </p:nvSpPr>
@@ -4733,7 +5254,7 @@
       </p:sp>
       <p:sp>
         <p:nvSpPr>
-          <p:cNvPr id="5" name="Text 3"/>
+          <p:cNvPr id="7" name="Text 4"/>
           <p:cNvSpPr txBox="1"/>
           <p:nvPr/>
         </p:nvSpPr>
@@ -4772,7 +5293,7 @@
       </p:sp>
       <p:sp>
         <p:nvSpPr>
-          <p:cNvPr id="6" name="Text 4"/>
+          <p:cNvPr id="8" name="Text 5"/>
           <p:cNvSpPr txBox="1"/>
           <p:nvPr/>
         </p:nvSpPr>
@@ -4908,9 +5429,72 @@
           <a:chExt cx="0" cy="0"/>
         </a:xfrm>
       </p:grpSpPr>
-      <p:sp>
-        <p:nvSpPr>
-          <p:cNvPr id="2" name="Text 0"/>
+      <p:pic>
+        <p:nvPicPr>
+          <p:cNvPr id="2" name="Image 0" descr="logo_w.png">    </p:cNvPr>
+          <p:cNvPicPr>
+            <a:picLocks noChangeAspect="1"/>
+          </p:cNvPicPr>
+          <p:nvPr/>
+        </p:nvPicPr>
+        <p:blipFill>
+          <a:blip r:embed="rId1"/>
+          <a:stretch>
+            <a:fillRect/>
+          </a:stretch>
+        </p:blipFill>
+        <p:spPr>
+          <a:xfrm>
+            <a:off x="640080" y="640080"/>
+            <a:ext cx="324964" cy="384048"/>
+          </a:xfrm>
+          <a:prstGeom prst="rect">
+            <a:avLst/>
+          </a:prstGeom>
+        </p:spPr>
+      </p:pic>
+      <p:sp>
+        <p:nvSpPr>
+          <p:cNvPr id="3" name="Text 0"/>
+          <p:cNvSpPr txBox="1"/>
+          <p:nvPr/>
+        </p:nvSpPr>
+        <p:spPr>
+          <a:xfrm>
+            <a:off x="1093060" y="621792"/>
+            <a:ext cx="1792224" cy="420624"/>
+          </a:xfrm>
+          <a:prstGeom prst="rect">
+            <a:avLst/>
+          </a:prstGeom>
+          <a:noFill/>
+          <a:ln/>
+        </p:spPr>
+        <p:txBody>
+          <a:bodyPr wrap="square" lIns="0" tIns="0" rIns="0" bIns="0" rtlCol="0" anchor="ctr"/>
+          <a:lstStyle/>
+          <a:p>
+            <a:pPr indent="0" marL="0">
+              <a:buNone/>
+            </a:pPr>
+            <a:r>
+              <a:rPr lang="en-US" sz="1680" b="1" spc="400" kern="0" dirty="0">
+                <a:solidFill>
+                  <a:srgbClr val="FFFFFF"/>
+                </a:solidFill>
+                <a:latin typeface="Calibri" pitchFamily="34" charset="0"/>
+                <a:ea typeface="Calibri" pitchFamily="34" charset="-122"/>
+                <a:cs typeface="Calibri" pitchFamily="34" charset="-120"/>
+              </a:rPr>
+              <a:t>PLUMB</a:t>
+            </a:r>
+            <a:endParaRPr lang="en-US" sz="1680" dirty="0"/>
+          </a:p>
+        </p:txBody>
+      </p:sp>
+      <p:sp>
+        <p:nvSpPr>
+          <p:cNvPr id="4" name="Text 1"/>
           <p:cNvSpPr txBox="1"/>
           <p:nvPr/>
         </p:nvSpPr>
@@ -4949,7 +5533,7 @@
       </p:sp>
       <p:sp>
         <p:nvSpPr>
-          <p:cNvPr id="3" name="Shape 1"/>
+          <p:cNvPr id="5" name="Shape 2"/>
           <p:cNvSpPr/>
           <p:nvPr/>
         </p:nvSpPr>
@@ -4974,7 +5558,7 @@
       </p:sp>
       <p:sp>
         <p:nvSpPr>
-          <p:cNvPr id="4" name="Text 2"/>
+          <p:cNvPr id="6" name="Text 3"/>
           <p:cNvSpPr txBox="1"/>
           <p:nvPr/>
         </p:nvSpPr>

</xml_diff>

<commit_message>
Title: Head of Product across deck, case study and demo
</commit_message>
<xml_diff>
--- a/docs/pitch/PLUMB_Pitch_Deck.pptx
+++ b/docs/pitch/PLUMB_Pitch_Deck.pptx
@@ -2086,7 +2086,7 @@
                 <a:ea typeface="Calibri" pitchFamily="34" charset="-122"/>
                 <a:cs typeface="Calibri" pitchFamily="34" charset="-120"/>
               </a:rPr>
-              <a:t>J John Britto  |  Head of Product &amp; Technology  |  100xEngineers Cohort 7 capstone  |  Solo</a:t>
+              <a:t>J John Britto  |  Head of Product  |  100xEngineers Cohort 7 capstone  |  Solo</a:t>
             </a:r>
             <a:endParaRPr lang="en-US" sz="1200" dirty="0"/>
           </a:p>
@@ -5285,7 +5285,7 @@
                 <a:ea typeface="Calibri" pitchFamily="34" charset="-122"/>
                 <a:cs typeface="Calibri" pitchFamily="34" charset="-120"/>
               </a:rPr>
-              <a:t>Head of Product &amp; Technology, Bengaluru</a:t>
+              <a:t>Head of Product, Bengaluru</a:t>
             </a:r>
             <a:endParaRPr lang="en-US" sz="1500" dirty="0"/>
           </a:p>
@@ -5328,7 +5328,7 @@
                 <a:ea typeface="Calibri" pitchFamily="34" charset="-122"/>
                 <a:cs typeface="Calibri" pitchFamily="34" charset="-120"/>
               </a:rPr>
-              <a:t>8+ years in AdTech, from UI/UX designer to Head of Product &amp; Technology</a:t>
+              <a:t>8+ years in AdTech, from UI/UX designer to Head of Product</a:t>
             </a:r>
             <a:endParaRPr lang="en-US" sz="1500" dirty="0"/>
           </a:p>

</xml_diff>

<commit_message>
README: Drive links; remove internal wording from deck notes
</commit_message>
<xml_diff>
--- a/docs/pitch/PLUMB_Pitch_Deck.pptx
+++ b/docs/pitch/PLUMB_Pitch_Deck.pptx
@@ -881,7 +881,7 @@
           <a:p>
             <a:r>
               <a:rPr lang="en-US" dirty="0"/>
-              <a:t>Floors are nudged placement by placement on a belief about fill rate. Good moves are never made because evidence is unclear; bad moves are made because a one-day swing was read as a trend. The 78.7% and 16.3% come from the modelled manual arm in the sample world, so read it as direction, not as a measured gap.</a:t>
+              <a:t>Floors are nudged placement by placement on a belief about fill rate. Good moves are never made because evidence is unclear; bad moves are made because a one-day swing was read as a trend. The 78.7% and 16.3% come from the modelled manual arm in the sample world, so it shows direction, not a measured gap.</a:t>
             </a:r>
             <a:endParaRPr lang="en-US" dirty="0"/>
           </a:p>
@@ -1145,7 +1145,7 @@
           <a:p>
             <a:r>
               <a:rPr lang="en-US" dirty="0"/>
-              <a:t>Add real validation here before presenting if you have it: user conversations, a pilot, a commitment. This deck states only what can be checked in the repo. Do not add a claim you cannot show.</a:t>
+              <a:t>Everything on this slide can be checked in the repo: the sample data, the evaluation, the pilot design tests and the CI run. The next step is a matched-cell pilot with real ops colleagues.</a:t>
             </a:r>
             <a:endParaRPr lang="en-US" dirty="0"/>
           </a:p>
@@ -1233,7 +1233,7 @@
           <a:p>
             <a:r>
               <a:rPr lang="en-US" dirty="0"/>
-              <a:t>Tuned on one sample world, frozen, scored on a fresh one. Intervals are cluster bootstraps over cells. The manual arm is my model of manual pricing, so quote the direction, not the size of the gap.</a:t>
+              <a:t>Tuned on one sample world, frozen, scored on a fresh one. Intervals are cluster bootstraps over cells. The manual arm is my model of manual pricing, so the direction is reliable and the size of the gap is not.</a:t>
             </a:r>
             <a:endParaRPr lang="en-US" dirty="0"/>
           </a:p>

</xml_diff>